<commit_message>
Identity update - headwinds/tailwinds
</commit_message>
<xml_diff>
--- a/decks/headwinds-and-tailwinds-lesson-v2.pptx
+++ b/decks/headwinds-and-tailwinds-lesson-v2.pptx
@@ -862,7 +862,7 @@
           <a:lstStyle/>
           <a:p>
             <a:r>
-              <a:t>4 MINUTES. This is the heart of the lesson; say it calmly and plainly. Give two or three everyday examples: being followed less in stores, seeing people who look like you in books and in charge, a name read the same way on a job application (resumes with white-sounding names got about 50 percent more callbacks in one well-known study). Say: "Many white people never notice, because nobody notices a wind they don't feel." Then say clearly: "A white student whose family is struggling has real headwinds. Race and money are different winds." Don't ask students of color to confirm or add examples.</a:t>
+              <a:t>OPTIONAL CLIP: before the slide, show a minute or two of pack racing from Rapha Gone Racing - Tulsa Tough (youtube.com/watch?v=5nP8J0D0ynA, about 25 minutes, unrated; preview it first). L39ION of Los Angeles is a Black-owned pro team started by brothers Justin and Cory Williams, who grew up on 39th Street in South Los Angeles. Justin started racing at 13, and the team mentors young Black and Latino riders. Watch how the riders tuck in behind each other. In Tulsa they wore a Greenwood Ave. patch honoring the 1921 Tulsa Race Massacre. If you show the clip, trim the talk below to fit. 4 MINUTES. This is the heart of the lesson; say it calmly and plainly. Give two or three everyday examples: being followed less in stores, seeing people who look like you in books and in charge, a name read the same way on a job application (resumes with white-sounding names got about 50 percent more callbacks in one well-known study). Say: "Many white people never notice, because nobody notices a wind they don't feel." Then say clearly: "A white student whose family is struggling has real headwinds. Race and money are different winds." Don't ask students of color to confirm or add examples.</a:t>
             </a:r>
           </a:p>
         </p:txBody>
@@ -4307,6 +4307,22 @@
                 </a:solidFill>
                 <a:latin typeface="Source Serif 4"/>
               </a:rPr>
+              <a:t>Optional: a minute or two of race footage from Rapha's film on L39ION of Los Angeles at Tulsa Tough (youtube.com/watch?v=5nP8J0D0ynA). Preview it first and cue up a stretch of pack racing.</a:t>
+            </a:r>
+          </a:p>
+          <a:p>
+            <a:pPr algn="l">
+              <a:spcAft>
+                <a:spcPts val="675"/>
+              </a:spcAft>
+            </a:pPr>
+            <a:r>
+              <a:rPr sz="1500" b="0" i="0">
+                <a:solidFill>
+                  <a:srgbClr val="1C1B19"/>
+                </a:solidFill>
+                <a:latin typeface="Source Serif 4"/>
+              </a:rPr>
               <a:t>The student page link (last slide) to share after advisory</a:t>
             </a:r>
           </a:p>
@@ -6509,6 +6525,54 @@
                 <a:latin typeface="Source Serif 4"/>
               </a:rPr>
               <a:t>Money, citizenship, English at home, ability, gender, being straight or cisgender, parents who went to college. Name several so the idea is clear, then name race directly so it doesn't get lost.</a:t>
+            </a:r>
+          </a:p>
+          <a:p>
+            <a:pPr algn="l">
+              <a:spcAft>
+                <a:spcPts val="585"/>
+              </a:spcAft>
+            </a:pPr>
+            <a:r>
+              <a:rPr sz="1300" b="0" i="0">
+                <a:solidFill>
+                  <a:srgbClr val="1C1B19"/>
+                </a:solidFill>
+                <a:latin typeface="Source Serif 4"/>
+              </a:rPr>
+              <a:t/>
+            </a:r>
+          </a:p>
+          <a:p>
+            <a:pPr algn="l">
+              <a:spcAft>
+                <a:spcPts val="585"/>
+              </a:spcAft>
+            </a:pPr>
+            <a:r>
+              <a:rPr sz="1500" b="1" i="0">
+                <a:solidFill>
+                  <a:srgbClr val="1C1B19"/>
+                </a:solidFill>
+                <a:latin typeface="Source Serif 4"/>
+              </a:rPr>
+              <a:t>Show who rides at the front.</a:t>
+            </a:r>
+          </a:p>
+          <a:p>
+            <a:pPr algn="l">
+              <a:spcAft>
+                <a:spcPts val="585"/>
+              </a:spcAft>
+            </a:pPr>
+            <a:r>
+              <a:rPr sz="1300" b="0" i="0">
+                <a:solidFill>
+                  <a:srgbClr val="1C1B19"/>
+                </a:solidFill>
+                <a:latin typeface="Source Serif 4"/>
+              </a:rPr>
+              <a:t>If you use the L39ION clip, let it stand as a team at the top of its sport, not as a lesson about hardship. Justin Williams built it to widen who gets to see themselves in cycling.</a:t>
             </a:r>
           </a:p>
           <a:p>

</xml_diff>